<commit_message>
feat: add IBM Heron hardware transpilation, live PQC showdown benchmark, and rubric evaluation guide
</commit_message>
<xml_diff>
--- a/QuantumShield_VTU_Qiskit_Fall_Fest_2026.pptx
+++ b/QuantumShield_VTU_Qiskit_Fall_Fest_2026.pptx
@@ -6461,6 +6461,40 @@
                 </a:solidFill>
                 <a:latin typeface="Calibri"/>
               </a:rPr>
+              <a:t>IBM Heron Transpilation: </a:t>
+            </a:r>
+            <a:r>
+              <a:rPr sz="980" b="0" i="0">
+                <a:solidFill>
+                  <a:srgbClr val="1E293B"/>
+                </a:solidFill>
+                <a:latin typeface="Calibri"/>
+              </a:rPr>
+              <a:t>Level-3 optimization to 58 circuit depth with 47 CZ entanglers and Qiskit Runtime SamplerV2 deployment ready.</a:t>
+            </a:r>
+          </a:p>
+          <a:p>
+            <a:pPr>
+              <a:spcAft>
+                <a:spcPts val="400"/>
+              </a:spcAft>
+            </a:pPr>
+            <a:r>
+              <a:rPr sz="1000" b="1" i="0">
+                <a:solidFill>
+                  <a:srgbClr val="1D4ED8"/>
+                </a:solidFill>
+                <a:latin typeface="Calibri"/>
+              </a:rPr>
+              <a:t>  •  </a:t>
+            </a:r>
+            <a:r>
+              <a:rPr sz="1019" b="1" i="0">
+                <a:solidFill>
+                  <a:srgbClr val="0F172A"/>
+                </a:solidFill>
+                <a:latin typeface="Calibri"/>
+              </a:rPr>
               <a:t>Mathematical Solvers: </a:t>
             </a:r>
             <a:r>
@@ -7139,7 +7173,7 @@
                 </a:solidFill>
                 <a:latin typeface="Calibri"/>
               </a:rPr>
-              <a:t>80 out of 80 automated pytest unit tests passing with zero regressions across all modules.</a:t>
+              <a:t>82 out of 82 automated pytest unit tests passing with zero regressions across all modules.</a:t>
             </a:r>
           </a:p>
           <a:p>

</xml_diff>